<commit_message>
Killercoda como lab primario y sus limites en el material
Co-Authored-By: Claude Opus 5 <noreply@anthropic.com>
</commit_message>
<xml_diff>
--- a/Arquitectura de Sistemas Computacionales/Clases/Clase 3 - Virtualizacion y contenedores/Presentacion.pptx
+++ b/Arquitectura de Sistemas Computacionales/Clases/Clase 3 - Virtualizacion y contenedores/Presentacion.pptx
@@ -3299,7 +3299,7 @@
                 </a:solidFill>
                 <a:latin typeface="Calibri"/>
               </a:rPr>
-              <a:t>Lab LabEx Docker Playground → stub CloudLite</a:t>
+              <a:t>Lab Killercoda → stub CloudLite</a:t>
             </a:r>
           </a:p>
         </p:txBody>
@@ -4221,7 +4221,7 @@
       </p:sp>
       <p:pic>
         <p:nvPicPr>
-          <p:cNvPr id="9" name="Picture 8" descr="labex.png"/>
+          <p:cNvPr id="9" name="Picture 8" descr="killercoda.png"/>
           <p:cNvPicPr>
             <a:picLocks noChangeAspect="1"/>
           </p:cNvPicPr>
@@ -4271,7 +4271,7 @@
                 </a:solidFill>
                 <a:latin typeface="Calibri"/>
               </a:rPr>
-              <a:t>LabEx Docker Playground</a:t>
+              <a:t>Killercoda</a:t>
             </a:r>
           </a:p>
           <a:p>
@@ -4287,7 +4287,7 @@
                 </a:solidFill>
                 <a:latin typeface="Calibri"/>
               </a:rPr>
-              <a:t>Lab del dia</a:t>
+              <a:t>Lab del dia · sesion 1 h</a:t>
             </a:r>
           </a:p>
         </p:txBody>
@@ -4425,7 +4425,7 @@
       </p:sp>
       <p:pic>
         <p:nvPicPr>
-          <p:cNvPr id="14" name="Picture 13" descr="killercoda.png"/>
+          <p:cNvPr id="14" name="Picture 13" descr="labex.png"/>
           <p:cNvPicPr>
             <a:picLocks noChangeAspect="1"/>
           </p:cNvPicPr>
@@ -4475,7 +4475,7 @@
                 </a:solidFill>
                 <a:latin typeface="Calibri"/>
               </a:rPr>
-              <a:t>Killercoda</a:t>
+              <a:t>LabEx Docker Playground</a:t>
             </a:r>
           </a:p>
           <a:p>
@@ -4491,7 +4491,7 @@
                 </a:solidFill>
                 <a:latin typeface="Calibri"/>
               </a:rPr>
-              <a:t>Alterna si no carga</a:t>
+              <a:t>Alterna · 3 al dia</a:t>
             </a:r>
           </a:p>
         </p:txBody>
@@ -6333,7 +6333,7 @@
                 </a:solidFill>
                 <a:latin typeface="Calibri"/>
               </a:rPr>
-              <a:t> Paso 4: abra LabEx Docker Playground en labex.io con su cuenta de Google o Microsoft (o Killercoda si no carga), ejecute docker build -t cloudlite-api:v1 . y docker run -d -p 8080:8080 cloudlite-api:v1, compruebe con curl que la ruta de salud devuelve 200 y llene la bitacora de 5 filas comando / que esperaba / que salio / evidencia, verificando que la captura muestre a la vez el prompt del lab, la salida del docker ps y la hora del sistema.</a:t>
+              <a:t> Paso 4: abra Killercoda en killercoda.com con su cuenta gratuita y lance un escenario Ubuntu (si no carga, LabEx Docker Playground como alterna; ojo: LabEx solo da 3 sesiones al dia en el plan gratuito), ejecute docker build -t cloudlite-api:v1 . y docker run -d -p 8080:8080 cloudlite-api:v1, compruebe con curl que la ruta de salud devuelve 200 y llene la bitacora de 5 filas comando / que esperaba / que salio / evidencia, verificando que la captura muestre a la vez el prompt del lab, la salida del docker ps y la hora del sistema.</a:t>
             </a:r>
           </a:p>
           <a:p>
@@ -8074,7 +8074,7 @@
                 </a:solidFill>
                 <a:latin typeface="Calibri"/>
               </a:rPr>
-              <a:t>LabEx Docker Playground · alterna si no carga: Killercoda</a:t>
+              <a:t>Killercoda · alterna si no carga: LabEx Docker Playground</a:t>
             </a:r>
           </a:p>
           <a:p>
@@ -8630,7 +8630,25 @@
                 </a:solidFill>
                 <a:latin typeface="Calibri"/>
               </a:rPr>
-              <a:t>–   Abrir LabEx Docker Playground (labex.io, inicie sesión con su cuenta de Google o Microsoft).</a:t>
+              <a:t>–   Abrir </a:t>
+            </a:r>
+            <a:r>
+              <a:rPr sz="1600" b="1" i="0">
+                <a:solidFill>
+                  <a:srgbClr val="333333"/>
+                </a:solidFill>
+                <a:latin typeface="Calibri"/>
+              </a:rPr>
+              <a:t>Killercoda</a:t>
+            </a:r>
+            <a:r>
+              <a:rPr sz="1600" b="0" i="0">
+                <a:solidFill>
+                  <a:srgbClr val="333333"/>
+                </a:solidFill>
+                <a:latin typeface="Calibri"/>
+              </a:rPr>
+              <a:t> (killercoda.com, escenario Ubuntu) con cuenta gratuita.</a:t>
             </a:r>
           </a:p>
           <a:p>
@@ -8680,7 +8698,7 @@
                 </a:solidFill>
                 <a:latin typeface="Calibri"/>
               </a:rPr>
-              <a:t>–   Home del lab · `docker ps`.</a:t>
+              <a:t>–   `docker ps` con el contenedor arriba.</a:t>
             </a:r>
           </a:p>
           <a:p>
@@ -8696,7 +8714,95 @@
                 </a:solidFill>
                 <a:latin typeface="Calibri"/>
               </a:rPr>
-              <a:t>–   La sesión de LabEx es temporal: guardar Dockerfile + capturas con timestamp antes de cerrarla. Si LabEx está caído: Killercoda (ubuntu/docker) como alterna.</a:t>
+              <a:t>–   </a:t>
+            </a:r>
+            <a:r>
+              <a:rPr sz="1600" b="1" i="0">
+                <a:solidFill>
+                  <a:srgbClr val="333333"/>
+                </a:solidFill>
+                <a:latin typeface="Calibri"/>
+              </a:rPr>
+              <a:t>La sesión caduca a 1 h:</a:t>
+            </a:r>
+            <a:r>
+              <a:rPr sz="1600" b="0" i="0">
+                <a:solidFill>
+                  <a:srgbClr val="333333"/>
+                </a:solidFill>
+                <a:latin typeface="Calibri"/>
+              </a:rPr>
+              <a:t> el Dockerfile se escribe en </a:t>
+            </a:r>
+            <a:r>
+              <a:rPr sz="1600" b="1" i="0">
+                <a:solidFill>
+                  <a:srgbClr val="333333"/>
+                </a:solidFill>
+                <a:latin typeface="Calibri"/>
+              </a:rPr>
+              <a:t>tu</a:t>
+            </a:r>
+            <a:r>
+              <a:rPr sz="1600" b="0" i="0">
+                <a:solidFill>
+                  <a:srgbClr val="333333"/>
+                </a:solidFill>
+                <a:latin typeface="Calibri"/>
+              </a:rPr>
+              <a:t> carpeta del PI y se pega en el lab, nunca al contrario. Guarda capturas antes de cerrar.</a:t>
+            </a:r>
+          </a:p>
+          <a:p>
+            <a:pPr>
+              <a:spcAft>
+                <a:spcPts val="800"/>
+              </a:spcAft>
+            </a:pPr>
+            <a:r>
+              <a:rPr sz="1600" b="0" i="0">
+                <a:solidFill>
+                  <a:srgbClr val="333333"/>
+                </a:solidFill>
+                <a:latin typeface="Calibri"/>
+              </a:rPr>
+              <a:t>–   Si Killercoda no carga: </a:t>
+            </a:r>
+            <a:r>
+              <a:rPr sz="1600" b="1" i="0">
+                <a:solidFill>
+                  <a:srgbClr val="333333"/>
+                </a:solidFill>
+                <a:latin typeface="Calibri"/>
+              </a:rPr>
+              <a:t>LabEx Docker Playground</a:t>
+            </a:r>
+            <a:r>
+              <a:rPr sz="1600" b="0" i="0">
+                <a:solidFill>
+                  <a:srgbClr val="333333"/>
+                </a:solidFill>
+                <a:latin typeface="Calibri"/>
+              </a:rPr>
+              <a:t> como alterna (misma hora de sesión, pero solo </a:t>
+            </a:r>
+            <a:r>
+              <a:rPr sz="1600" b="1" i="0">
+                <a:solidFill>
+                  <a:srgbClr val="333333"/>
+                </a:solidFill>
+                <a:latin typeface="Calibri"/>
+              </a:rPr>
+              <a:t>3 al día</a:t>
+            </a:r>
+            <a:r>
+              <a:rPr sz="1600" b="0" i="0">
+                <a:solidFill>
+                  <a:srgbClr val="333333"/>
+                </a:solidFill>
+                <a:latin typeface="Calibri"/>
+              </a:rPr>
+              <a:t> en el plan gratuito).</a:t>
             </a:r>
           </a:p>
         </p:txBody>

</xml_diff>